<commit_message>
Fix license due date
</commit_message>
<xml_diff>
--- a/lectures/Session03-OpenSource.pptx
+++ b/lectures/Session03-OpenSource.pptx
@@ -778,7 +778,7 @@
           <a:p>
             <a:r>
               <a:rPr lang="en-US" dirty="0"/>
-              <a:t>Walk through the License/OSS short response — about one page: pick and name a license for the project they're imagining, explain in plain terms what it lets others do and not do and why it fits their goals, and name one governance choice they'd make and why. Point them to the cheat sheet and choosealicense.com. Confirm the due date aloud so it matches the LMS. ~2 min.</a:t>
+              <a:t>Walk through the License/OSS short response — about one page: pick and name a license for the project they're imagining, explain in plain terms what it lets others do and not do and why it fits their goals, and name one governance choice they'd make and why. Point them to the cheat sheet and choosealicense.com. Confirm the due date aloud (Mon, Sep 21) so it matches the LMS. ~2 min.</a:t>
             </a:r>
             <a:endParaRPr lang="en-US" dirty="0"/>
           </a:p>
@@ -866,7 +866,7 @@
           <a:p>
             <a:r>
               <a:rPr lang="en-US" dirty="0"/>
-              <a:t>Close on the through-line: building in the open is how a project becomes something others can join. Assign the Session 4 discovery readings (see the Session 4 page), the License/OSS short response, and keep feeding the journal. Preview Wednesday — the discovery workshop, talking to real users, where the discovery assignment kicks off. ~1-2 min.</a:t>
+              <a:t>Close on the through-line: building in the open is how a project becomes something others can join. Before Wednesday's discovery workshop: the Session 4 readings and keep feeding the journal. The License/OSS short response is due Mon, Sep 21 (Week 3) — say the date aloud so it matches the LMS. Preview Wednesday — talking to real users, where the discovery assignment kicks off. ~1-2 min.</a:t>
             </a:r>
             <a:endParaRPr lang="en-US" dirty="0"/>
           </a:p>
@@ -4565,7 +4565,7 @@
                 <a:ea typeface="Calibri" pitchFamily="34" charset="-122"/>
                 <a:cs typeface="Calibri" pitchFamily="34" charset="-120"/>
               </a:rPr>
-              <a:t>BEFORE WEDNESDAY, SEP 16</a:t>
+              <a:t>BEFORE NEXT CLASS — WED, SEP 16</a:t>
             </a:r>
             <a:endParaRPr lang="en-US" sz="1400" dirty="0"/>
           </a:p>
@@ -4629,7 +4629,7 @@
                 <a:ea typeface="Calibri" pitchFamily="34" charset="-122"/>
                 <a:cs typeface="Calibri" pitchFamily="34" charset="-120"/>
               </a:rPr>
-              <a:t>Write your License / OSS short response</a:t>
+              <a:t>Keep feeding your idea journal — next up: talking to real users</a:t>
             </a:r>
             <a:endParaRPr lang="en-US" sz="1650" dirty="0"/>
           </a:p>
@@ -4647,7 +4647,7 @@
                 <a:ea typeface="Calibri" pitchFamily="34" charset="-122"/>
                 <a:cs typeface="Calibri" pitchFamily="34" charset="-120"/>
               </a:rPr>
-              <a:t>Keep feeding your idea journal — next up: talking to real users</a:t>
+              <a:t>Write your License / OSS short response — due Mon, Sep 21</a:t>
             </a:r>
             <a:endParaRPr lang="en-US" sz="1650" dirty="0"/>
           </a:p>

</xml_diff>